<commit_message>
feat: chart and diagram text, Markdown output
Charts contribute their cached title, series names, categories and values
(standard `c:chartSpace` and the 2014 `cx:chartSpace`), diagrams their
nodes in tree order from the data model's parent connections; both join
the slide text by default and switch off with `charts`/`diagrams`
options (`--no-charts`, `--no-diagrams`). `Slide::charts` and
`Slide::diagrams` return the data structured. `pptxboss markdown`,
`Document::markdown` and the Python `markdown()` methods render a deck as
a heading per slide, bullets with levels, GFM tables, images, chart
tables, diagram outlines, embedded-object labels, and notes and comments
as block quotes on request.

Verified: 88 core, 17 document, 66 verifier, 12 CLI and 22 Python tests;
clippy -D warnings; fmt. Chart data matches python-pptx's chart API on all
146 comparable charts in the corpus; a text and markdown sweep over 737
corpus files fails only on the two already-unreadable fuzzer archives.
</commit_message>
<xml_diff>
--- a/tests/fixtures/features.pptx
+++ b/tests/fixtures/features.pptx
@@ -8,6 +8,7 @@
     <p:sldId id="256" r:id="rId2"/>
     <p:sldId id="257" r:id="rId3"/>
     <p:sldId id="258" r:id="rId4"/>
+    <p:sldId id="259" r:id="rId5"/>
   </p:sldIdLst>
   <p:sldSz cx="12192000" cy="6858000"/>
   <p:notesSz cx="6858000" cy="9144000"/>
@@ -42,6 +43,55 @@
 </p:cmAuthorLst>
 </file>
 
+<file path=ppt/charts/chart1.xml><?xml version="1.0" encoding="utf-8"?>
+<c:chartSpace xmlns:c="http://schemas.openxmlformats.org/drawingml/2006/chart" xmlns:a="http://schemas.openxmlformats.org/drawingml/2006/main">
+  <c:chart>
+    <c:title>
+      <c:tx>
+        <c:rich>
+          <a:bodyPr/>
+          <a:p>
+            <a:r>
+              <a:t>Revenue</a:t>
+            </a:r>
+          </a:p>
+        </c:rich>
+      </c:tx>
+    </c:title>
+    <c:plotArea>
+      <c:barChart>
+        <c:ser>
+          <c:idx val="0"/>
+          <c:tx>
+            <c:v>2024</c:v>
+          </c:tx>
+          <c:cat>
+            <c:strLit>
+              <c:pt idx="0">
+                <c:v>Q1</c:v>
+              </c:pt>
+              <c:pt idx="1">
+                <c:v>Q2</c:v>
+              </c:pt>
+            </c:strLit>
+          </c:cat>
+          <c:val>
+            <c:numLit>
+              <c:pt idx="0">
+                <c:v>10</c:v>
+              </c:pt>
+              <c:pt idx="1">
+                <c:v>12</c:v>
+              </c:pt>
+            </c:numLit>
+          </c:val>
+        </c:ser>
+      </c:barChart>
+    </c:plotArea>
+  </c:chart>
+</c:chartSpace>
+</file>
+
 <file path=ppt/comments/comment1.xml><?xml version="1.0" encoding="utf-8"?>
 <p:cmLst xmlns:p="http://schemas.openxmlformats.org/presentationml/2006/main">
   <p:cm authorId="0" dt="2024-05-01T10:00:00.000" idx="1">
@@ -49,6 +99,54 @@
     <p:text>Tighten this point</p:text>
   </p:cm>
 </p:cmLst>
+</file>
+
+<file path=ppt/diagrams/data1.xml><?xml version="1.0" encoding="utf-8"?>
+<dgm:dataModel xmlns:dgm="http://schemas.openxmlformats.org/drawingml/2006/diagram" xmlns:a="http://schemas.openxmlformats.org/drawingml/2006/main">
+  <dgm:ptLst>
+    <dgm:pt modelId="{D0}" type="doc">
+      <dgm:t>
+        <a:bodyPr/>
+        <a:p/>
+      </dgm:t>
+    </dgm:pt>
+    <dgm:pt modelId="{N1}">
+      <dgm:t>
+        <a:bodyPr/>
+        <a:p>
+          <a:r>
+            <a:t>Plan</a:t>
+          </a:r>
+        </a:p>
+      </dgm:t>
+    </dgm:pt>
+    <dgm:pt modelId="{N2}">
+      <dgm:t>
+        <a:bodyPr/>
+        <a:p>
+          <a:r>
+            <a:t>Build</a:t>
+          </a:r>
+        </a:p>
+      </dgm:t>
+    </dgm:pt>
+    <dgm:pt modelId="{N3}">
+      <dgm:t>
+        <a:bodyPr/>
+        <a:p>
+          <a:r>
+            <a:t>Test first</a:t>
+          </a:r>
+        </a:p>
+      </dgm:t>
+    </dgm:pt>
+  </dgm:ptLst>
+  <dgm:cxnLst>
+    <dgm:cxn modelId="{C1}" srcId="{D0}" destId="{N1}" srcOrd="0" destOrd="0"/>
+    <dgm:cxn modelId="{C2}" srcId="{D0}" destId="{N2}" srcOrd="1" destOrd="0"/>
+    <dgm:cxn modelId="{C3}" srcId="{N2}" destId="{N3}" srcOrd="0" destOrd="0"/>
+  </dgm:cxnLst>
+</dgm:dataModel>
 </file>
 
 <file path=ppt/slideLayouts/slideLayout1.xml><?xml version="1.0" encoding="utf-8"?>
@@ -417,6 +515,85 @@
           </a:p>
         </p:txBody>
       </p:sp>
+    </p:spTree>
+  </p:cSld>
+  <p:clrMapOvr>
+    <a:masterClrMapping/>
+  </p:clrMapOvr>
+</p:sld>
+</file>
+
+<file path=ppt/slides/slide4.xml><?xml version="1.0" encoding="utf-8"?>
+<p:sld xmlns:a="http://schemas.openxmlformats.org/drawingml/2006/main" xmlns:r="http://schemas.openxmlformats.org/officeDocument/2006/relationships" xmlns:p="http://schemas.openxmlformats.org/presentationml/2006/main">
+  <p:cSld>
+    <p:spTree>
+      <p:nvGrpSpPr>
+        <p:cNvPr id="1" name=""/>
+        <p:cNvGrpSpPr/>
+        <p:nvPr/>
+      </p:nvGrpSpPr>
+      <p:grpSpPr>
+        <a:xfrm>
+          <a:off x="0" y="0"/>
+          <a:ext cx="0" cy="0"/>
+          <a:chOff x="0" y="0"/>
+          <a:chExt cx="0" cy="0"/>
+        </a:xfrm>
+      </p:grpSpPr>
+      <p:sp>
+        <p:nvSpPr>
+          <p:cNvPr id="2" name="Title 2"/>
+          <p:cNvSpPr>
+            <a:spLocks noGrp="1"/>
+          </p:cNvSpPr>
+          <p:nvPr>
+            <p:ph type="title"/>
+          </p:nvPr>
+        </p:nvSpPr>
+        <p:spPr/>
+        <p:txBody>
+          <a:bodyPr/>
+          <a:lstStyle/>
+          <a:p>
+            <a:r>
+              <a:rPr lang="en-US" dirty="0"/>
+              <a:t>Figures</a:t>
+            </a:r>
+          </a:p>
+        </p:txBody>
+      </p:sp>
+      <p:graphicFrame>
+        <p:nvGraphicFramePr>
+          <p:cNvPr id="7" name="Chart 6"/>
+          <p:cNvGraphicFramePr/>
+          <p:nvPr/>
+        </p:nvGraphicFramePr>
+        <p:xfrm>
+          <a:off x="0" y="0"/>
+          <a:ext cx="100" cy="100"/>
+        </p:xfrm>
+        <a:graphic>
+          <a:graphicData uri="http://schemas.openxmlformats.org/drawingml/2006/chart">
+            <c:chart xmlns:c="http://schemas.openxmlformats.org/drawingml/2006/chart" r:id="rId5"/>
+          </a:graphicData>
+        </a:graphic>
+      </p:graphicFrame>
+      <p:graphicFrame>
+        <p:nvGraphicFramePr>
+          <p:cNvPr id="8" name="Diagram 7"/>
+          <p:cNvGraphicFramePr/>
+          <p:nvPr/>
+        </p:nvGraphicFramePr>
+        <p:xfrm>
+          <a:off x="0" y="0"/>
+          <a:ext cx="100" cy="100"/>
+        </p:xfrm>
+        <a:graphic>
+          <a:graphicData uri="http://schemas.openxmlformats.org/drawingml/2006/diagram">
+            <dgm:relIds xmlns:dgm="http://schemas.openxmlformats.org/drawingml/2006/diagram" r:dm="rId6" r:lo="rId6" r:qs="rId6" r:cs="rId6"/>
+          </a:graphicData>
+        </a:graphic>
+      </p:graphicFrame>
     </p:spTree>
   </p:cSld>
   <p:clrMapOvr>

</xml_diff>